<commit_message>
docs: format presentation deck with Slide 1 (Title/Subtitle), Slide 2 (Presenter Info - Team: Talent Innovators), Slide 3 (Problem Understanding), Slide 4 (What We Solved)
</commit_message>
<xml_diff>
--- a/NEXORA_Presentation.pptx
+++ b/NEXORA_Presentation.pptx
@@ -12,6 +12,7 @@
     <p:sldId id="260" r:id="rId11"/>
     <p:sldId id="261" r:id="rId12"/>
     <p:sldId id="262" r:id="rId13"/>
+    <p:sldId id="263" r:id="rId14"/>
   </p:sldIdLst>
   <p:sldSz cx="12191695" cy="6858000" type="screen4x3"/>
   <p:notesSz cx="6858000" cy="9144000"/>
@@ -3172,7 +3173,7 @@
               </a:defRPr>
             </a:pPr>
             <a:r>
-              <a:t>NEXT-GENERATION AI LEARNING &amp; CAREER PLATFORM</a:t>
+              <a:t>AI-POWERED EDUCATIONAL &amp; CAREER PLATFORM</a:t>
             </a:r>
           </a:p>
           <a:p>
@@ -3202,7 +3203,7 @@
               </a:defRPr>
             </a:pPr>
             <a:r>
-              <a:t>Context-Aware Dynamic AI Learning Pathfinder &amp; Career Navigator</a:t>
+              <a:t>Context-Aware Dynamic AI Learning Pathfinder &amp; Placement Navigator</a:t>
             </a:r>
           </a:p>
           <a:p>
@@ -3217,7 +3218,7 @@
               </a:defRPr>
             </a:pPr>
             <a:r>
-              <a:t>Replacing static video playlists with real-time adaptive DAG roadmaps, automated diagnostic skill gap analysis, ATS resume intelligence, and 24/7 multimodal tutoring.</a:t>
+              <a:t>Empowering every learner with real-time adaptive roadmaps, automated diagnostic skill gap matrices, and 24/7 personalized AI guidance.</a:t>
             </a:r>
           </a:p>
           <a:p>
@@ -3229,7 +3230,7 @@
               </a:defRPr>
             </a:pPr>
             <a:r>
-              <a:t>Live Web App: https://nexora-path-finder.vercel.app  |  Powered by Google Gemini AI &amp; React 19</a:t>
+              <a:t>Live Deployment: https://nexora-path-finder.vercel.app  |  Powered by Google Gemini AI</a:t>
             </a:r>
           </a:p>
         </p:txBody>
@@ -3330,7 +3331,7 @@
               </a:defRPr>
             </a:pPr>
             <a:r>
-              <a:t>INDUSTRY CHALLENGE</a:t>
+              <a:t>TEAM &amp; PRESENTER INFORMATION</a:t>
             </a:r>
           </a:p>
           <a:p>
@@ -3342,7 +3343,7 @@
               </a:defRPr>
             </a:pPr>
             <a:r>
-              <a:t>The Broken Student Learning Journey</a:t>
+              <a:t>Project Presentation Team</a:t>
             </a:r>
           </a:p>
           <a:p>
@@ -3357,7 +3358,360 @@
               </a:defRPr>
             </a:pPr>
             <a:r>
-              <a:t>Why 90% of online learners drop out or fail technical screening rounds</a:t>
+              <a:t>Information about the innovators behind NEXORA</a:t>
+            </a:r>
+          </a:p>
+        </p:txBody>
+      </p:sp>
+      <p:sp>
+        <p:nvSpPr>
+          <p:cNvPr id="4" name="Rounded Rectangle 3"/>
+          <p:cNvSpPr/>
+          <p:nvPr/>
+        </p:nvSpPr>
+        <p:spPr>
+          <a:xfrm>
+            <a:off x="731520" y="2011680"/>
+            <a:ext cx="5120640" cy="4114800"/>
+          </a:xfrm>
+          <a:prstGeom prst="roundRect">
+            <a:avLst/>
+          </a:prstGeom>
+          <a:solidFill>
+            <a:srgbClr val="131A2A"/>
+          </a:solidFill>
+          <a:ln>
+            <a:solidFill>
+              <a:srgbClr val="26324E"/>
+            </a:solidFill>
+          </a:ln>
+        </p:spPr>
+        <p:style>
+          <a:lnRef idx="1">
+            <a:schemeClr val="accent1"/>
+          </a:lnRef>
+          <a:fillRef idx="3">
+            <a:schemeClr val="accent1"/>
+          </a:fillRef>
+          <a:effectRef idx="2">
+            <a:schemeClr val="accent1"/>
+          </a:effectRef>
+          <a:fontRef idx="minor">
+            <a:schemeClr val="lt1"/>
+          </a:fontRef>
+        </p:style>
+        <p:txBody>
+          <a:bodyPr rtlCol="0" anchor="ctr" wrap="square" lIns="365760" rIns="365760" tIns="320040"/>
+          <a:lstStyle/>
+          <a:p>
+            <a:pPr algn="ctr">
+              <a:spcAft>
+                <a:spcPts val="800"/>
+              </a:spcAft>
+              <a:defRPr sz="1100" b="1">
+                <a:solidFill>
+                  <a:srgbClr val="38BDF8"/>
+                </a:solidFill>
+              </a:defRPr>
+            </a:pPr>
+            <a:r>
+              <a:t>TEAM DETAILS</a:t>
+            </a:r>
+          </a:p>
+          <a:p>
+            <a:pPr>
+              <a:defRPr sz="1300">
+                <a:solidFill>
+                  <a:srgbClr val="94A3B8"/>
+                </a:solidFill>
+              </a:defRPr>
+            </a:pPr>
+            <a:r>
+              <a:t>Team Name:</a:t>
+            </a:r>
+          </a:p>
+          <a:p>
+            <a:pPr>
+              <a:spcAft>
+                <a:spcPts val="2000"/>
+              </a:spcAft>
+              <a:defRPr sz="2200" b="1">
+                <a:solidFill>
+                  <a:srgbClr val="F8FAFC"/>
+                </a:solidFill>
+              </a:defRPr>
+            </a:pPr>
+            <a:r>
+              <a:t>Talent Innovators</a:t>
+            </a:r>
+          </a:p>
+          <a:p>
+            <a:pPr>
+              <a:defRPr sz="1300">
+                <a:solidFill>
+                  <a:srgbClr val="94A3B8"/>
+                </a:solidFill>
+              </a:defRPr>
+            </a:pPr>
+            <a:r>
+              <a:t>Project Track / Theme:</a:t>
+            </a:r>
+          </a:p>
+          <a:p>
+            <a:pPr>
+              <a:defRPr sz="1500" b="1">
+                <a:solidFill>
+                  <a:srgbClr val="6366F1"/>
+                </a:solidFill>
+              </a:defRPr>
+            </a:pPr>
+            <a:r>
+              <a:t>AI in Education, Adaptive Learning &amp; Career Readiness</a:t>
+            </a:r>
+          </a:p>
+        </p:txBody>
+      </p:sp>
+      <p:sp>
+        <p:nvSpPr>
+          <p:cNvPr id="5" name="Rounded Rectangle 4"/>
+          <p:cNvSpPr/>
+          <p:nvPr/>
+        </p:nvSpPr>
+        <p:spPr>
+          <a:xfrm>
+            <a:off x="6217920" y="2011680"/>
+            <a:ext cx="5212080" cy="4114800"/>
+          </a:xfrm>
+          <a:prstGeom prst="roundRect">
+            <a:avLst/>
+          </a:prstGeom>
+          <a:solidFill>
+            <a:srgbClr val="131A2A"/>
+          </a:solidFill>
+          <a:ln>
+            <a:solidFill>
+              <a:srgbClr val="26324E"/>
+            </a:solidFill>
+          </a:ln>
+        </p:spPr>
+        <p:style>
+          <a:lnRef idx="1">
+            <a:schemeClr val="accent1"/>
+          </a:lnRef>
+          <a:fillRef idx="3">
+            <a:schemeClr val="accent1"/>
+          </a:fillRef>
+          <a:effectRef idx="2">
+            <a:schemeClr val="accent1"/>
+          </a:effectRef>
+          <a:fontRef idx="minor">
+            <a:schemeClr val="lt1"/>
+          </a:fontRef>
+        </p:style>
+        <p:txBody>
+          <a:bodyPr rtlCol="0" anchor="ctr" wrap="square" lIns="365760" rIns="365760" tIns="320040"/>
+          <a:lstStyle/>
+          <a:p>
+            <a:pPr algn="ctr">
+              <a:spcAft>
+                <a:spcPts val="1200"/>
+              </a:spcAft>
+              <a:defRPr sz="1100" b="1">
+                <a:solidFill>
+                  <a:srgbClr val="34D399"/>
+                </a:solidFill>
+              </a:defRPr>
+            </a:pPr>
+            <a:r>
+              <a:t>TEAM MEMBERS</a:t>
+            </a:r>
+          </a:p>
+          <a:p>
+            <a:pPr>
+              <a:spcAft>
+                <a:spcPts val="1400"/>
+              </a:spcAft>
+              <a:defRPr sz="1300">
+                <a:solidFill>
+                  <a:srgbClr val="F8FAFC"/>
+                </a:solidFill>
+              </a:defRPr>
+            </a:pPr>
+            <a:r>
+              <a:t>1.  ___________________________________  (Team Lead)</a:t>
+            </a:r>
+          </a:p>
+          <a:p>
+            <a:pPr>
+              <a:spcAft>
+                <a:spcPts val="1400"/>
+              </a:spcAft>
+              <a:defRPr sz="1300">
+                <a:solidFill>
+                  <a:srgbClr val="F8FAFC"/>
+                </a:solidFill>
+              </a:defRPr>
+            </a:pPr>
+            <a:r>
+              <a:t>2.  ___________________________________  (Developer / AI)</a:t>
+            </a:r>
+          </a:p>
+          <a:p>
+            <a:pPr>
+              <a:spcAft>
+                <a:spcPts val="1400"/>
+              </a:spcAft>
+              <a:defRPr sz="1300">
+                <a:solidFill>
+                  <a:srgbClr val="F8FAFC"/>
+                </a:solidFill>
+              </a:defRPr>
+            </a:pPr>
+            <a:r>
+              <a:t>3.  ___________________________________  (Developer / UI)</a:t>
+            </a:r>
+          </a:p>
+          <a:p>
+            <a:pPr>
+              <a:spcAft>
+                <a:spcPts val="1400"/>
+              </a:spcAft>
+              <a:defRPr sz="1300">
+                <a:solidFill>
+                  <a:srgbClr val="F8FAFC"/>
+                </a:solidFill>
+              </a:defRPr>
+            </a:pPr>
+            <a:r>
+              <a:t>4.  ___________________________________  (Researcher / QA)</a:t>
+            </a:r>
+          </a:p>
+        </p:txBody>
+      </p:sp>
+    </p:spTree>
+  </p:cSld>
+  <p:clrMapOvr>
+    <a:masterClrMapping/>
+  </p:clrMapOvr>
+</p:sld>
+</file>
+
+<file path=ppt/slides/slide3.xml><?xml version="1.0" encoding="utf-8"?>
+<p:sld xmlns:a="http://schemas.openxmlformats.org/drawingml/2006/main" xmlns:p="http://schemas.openxmlformats.org/presentationml/2006/main" xmlns:r="http://schemas.openxmlformats.org/officeDocument/2006/relationships">
+  <p:cSld>
+    <p:spTree>
+      <p:nvGrpSpPr>
+        <p:cNvPr id="1" name=""/>
+        <p:cNvGrpSpPr/>
+        <p:nvPr/>
+      </p:nvGrpSpPr>
+      <p:grpSpPr/>
+      <p:sp>
+        <p:nvSpPr>
+          <p:cNvPr id="2" name="Rectangle 1"/>
+          <p:cNvSpPr/>
+          <p:nvPr/>
+        </p:nvSpPr>
+        <p:spPr>
+          <a:xfrm>
+            <a:off x="0" y="0"/>
+            <a:ext cx="12191695" cy="6858000"/>
+          </a:xfrm>
+          <a:prstGeom prst="rect">
+            <a:avLst/>
+          </a:prstGeom>
+          <a:solidFill>
+            <a:srgbClr val="0B0F19"/>
+          </a:solidFill>
+          <a:ln>
+            <a:solidFill>
+              <a:srgbClr val="0B0F19"/>
+            </a:solidFill>
+          </a:ln>
+        </p:spPr>
+        <p:style>
+          <a:lnRef idx="1">
+            <a:schemeClr val="accent1"/>
+          </a:lnRef>
+          <a:fillRef idx="3">
+            <a:schemeClr val="accent1"/>
+          </a:fillRef>
+          <a:effectRef idx="2">
+            <a:schemeClr val="accent1"/>
+          </a:effectRef>
+          <a:fontRef idx="minor">
+            <a:schemeClr val="lt1"/>
+          </a:fontRef>
+        </p:style>
+        <p:txBody>
+          <a:bodyPr rtlCol="0" anchor="ctr"/>
+          <a:lstStyle/>
+          <a:p>
+            <a:pPr algn="ctr"/>
+          </a:p>
+        </p:txBody>
+      </p:sp>
+      <p:sp>
+        <p:nvSpPr>
+          <p:cNvPr id="3" name="TextBox 2"/>
+          <p:cNvSpPr txBox="1"/>
+          <p:nvPr/>
+        </p:nvSpPr>
+        <p:spPr>
+          <a:xfrm>
+            <a:off x="731520" y="548640"/>
+            <a:ext cx="10698480" cy="1097280"/>
+          </a:xfrm>
+          <a:prstGeom prst="rect">
+            <a:avLst/>
+          </a:prstGeom>
+          <a:noFill/>
+        </p:spPr>
+        <p:txBody>
+          <a:bodyPr wrap="square" lIns="0" tIns="0" rIns="0" bIns="0">
+            <a:spAutoFit/>
+          </a:bodyPr>
+          <a:lstStyle/>
+          <a:p>
+            <a:pPr>
+              <a:spcAft>
+                <a:spcPts val="400"/>
+              </a:spcAft>
+              <a:defRPr sz="1100" b="1">
+                <a:solidFill>
+                  <a:srgbClr val="38BDF8"/>
+                </a:solidFill>
+              </a:defRPr>
+            </a:pPr>
+            <a:r>
+              <a:t>PROBLEM UNDERSTANDING</a:t>
+            </a:r>
+          </a:p>
+          <a:p>
+            <a:pPr>
+              <a:defRPr sz="2400" b="1">
+                <a:solidFill>
+                  <a:srgbClr val="F8FAFC"/>
+                </a:solidFill>
+              </a:defRPr>
+            </a:pPr>
+            <a:r>
+              <a:t>Key Challenges in Modern Technical Education</a:t>
+            </a:r>
+          </a:p>
+          <a:p>
+            <a:pPr>
+              <a:spcBef>
+                <a:spcPts val="400"/>
+              </a:spcBef>
+              <a:defRPr sz="1200">
+                <a:solidFill>
+                  <a:srgbClr val="94A3B8"/>
+                </a:solidFill>
+              </a:defRPr>
+            </a:pPr>
+            <a:r>
+              <a:t>Why traditional learning platforms fail 90% of students before job readiness</a:t>
             </a:r>
           </a:p>
         </p:txBody>
@@ -3414,7 +3768,7 @@
               </a:defRPr>
             </a:pPr>
             <a:r>
-              <a:t>01. Static &amp; Generic Playlists</a:t>
+              <a:t>01. Rigid, Linear Video Courses</a:t>
             </a:r>
           </a:p>
           <a:p>
@@ -3426,7 +3780,7 @@
               </a:defRPr>
             </a:pPr>
             <a:r>
-              <a:t>Traditional courses treat absolute beginners and experienced switchers identically, causing frustration, overwhelm, or redundant study.</a:t>
+              <a:t>Static video playlists treat absolute beginners and experienced learners identically, causing cognitive fatigue on known topics and abandonment on hard ones.</a:t>
             </a:r>
           </a:p>
         </p:txBody>
@@ -3495,7 +3849,7 @@
               </a:defRPr>
             </a:pPr>
             <a:r>
-              <a:t>Students attempt advanced concepts (like Dynamic Programming or Rotational Motion) without mastering foundational mechanics, leading to repeated failures.</a:t>
+              <a:t>Students jump directly into advanced topics (like Dynamic Programming or Rotational Dynamics) without mastering basic foundations, creating recurring bottlenecks.</a:t>
             </a:r>
           </a:p>
         </p:txBody>
@@ -3552,7 +3906,7 @@
               </a:defRPr>
             </a:pPr>
             <a:r>
-              <a:t>03. Analysis Paralysis</a:t>
+              <a:t>03. Analysis Paralysis &amp; Noise</a:t>
             </a:r>
           </a:p>
           <a:p>
@@ -3564,7 +3918,7 @@
               </a:defRPr>
             </a:pPr>
             <a:r>
-              <a:t>Thousands of unstructured YouTube videos and paid courses create confusion. Students don't know what single high-yield action to take today.</a:t>
+              <a:t>With millions of scattered YouTube videos and blog posts, students waste hours researching what they should realistically study today.</a:t>
             </a:r>
           </a:p>
         </p:txBody>
@@ -3621,7 +3975,7 @@
               </a:defRPr>
             </a:pPr>
             <a:r>
-              <a:t>04. Resume &amp; ATS Disconnect</a:t>
+              <a:t>04. The Industry Screening Disconnect</a:t>
             </a:r>
           </a:p>
           <a:p>
@@ -3633,7 +3987,7 @@
               </a:defRPr>
             </a:pPr>
             <a:r>
-              <a:t>Even after completing courses, students struggle to translate learned skills into ATS-compliant bullet points and measurable recruiter-ready metrics.</a:t>
+              <a:t>Learners finish tutorials but fail technical screening rounds because they lack ATS-optimized resume formatting and verified diagnostic assessment proof.</a:t>
             </a:r>
           </a:p>
         </p:txBody>
@@ -3646,7 +4000,7 @@
 </p:sld>
 </file>
 
-<file path=ppt/slides/slide3.xml><?xml version="1.0" encoding="utf-8"?>
+<file path=ppt/slides/slide4.xml><?xml version="1.0" encoding="utf-8"?>
 <p:sld xmlns:a="http://schemas.openxmlformats.org/drawingml/2006/main" xmlns:p="http://schemas.openxmlformats.org/presentationml/2006/main" xmlns:r="http://schemas.openxmlformats.org/officeDocument/2006/relationships">
   <p:cSld>
     <p:spTree>
@@ -3734,7 +4088,7 @@
               </a:defRPr>
             </a:pPr>
             <a:r>
-              <a:t>PRODUCT ARCHITECTURE</a:t>
+              <a:t>OUR SOLUTION</a:t>
             </a:r>
           </a:p>
           <a:p>
@@ -3746,7 +4100,7 @@
               </a:defRPr>
             </a:pPr>
             <a:r>
-              <a:t>The 7 Intelligent Pillars of NEXORA</a:t>
+              <a:t>What We Solved with NEXORA</a:t>
             </a:r>
           </a:p>
           <a:p>
@@ -3761,7 +4115,7 @@
               </a:defRPr>
             </a:pPr>
             <a:r>
-              <a:t>An end-to-end adaptive ecosystem built around student mastery</a:t>
+              <a:t>A complete paradigm shift from passive video consumption to active, goal-driven navigation</a:t>
             </a:r>
           </a:p>
         </p:txBody>
@@ -3774,8 +4128,8 @@
         </p:nvSpPr>
         <p:spPr>
           <a:xfrm>
-            <a:off x="731520" y="1920240"/>
-            <a:ext cx="5212080" cy="1051560"/>
+            <a:off x="731520" y="2011680"/>
+            <a:ext cx="3383280" cy="1920240"/>
           </a:xfrm>
           <a:prstGeom prst="roundRect">
             <a:avLst/>
@@ -3804,18 +4158,21 @@
           </a:fontRef>
         </p:style>
         <p:txBody>
-          <a:bodyPr rtlCol="0" anchor="ctr" wrap="square" lIns="182880" rIns="182880" tIns="109728"/>
+          <a:bodyPr rtlCol="0" anchor="ctr" wrap="square" lIns="182880" rIns="182880" tIns="182880"/>
           <a:lstStyle/>
           <a:p>
             <a:pPr algn="ctr">
-              <a:defRPr sz="1300" b="1">
+              <a:spcAft>
+                <a:spcPts val="600"/>
+              </a:spcAft>
+              <a:defRPr sz="1350" b="1">
                 <a:solidFill>
                   <a:srgbClr val="38BDF8"/>
                 </a:solidFill>
               </a:defRPr>
             </a:pPr>
             <a:r>
-              <a:t>1. Conversational AI Onboarding</a:t>
+              <a:t>✅ Dynamic Flowchart DAGs</a:t>
             </a:r>
           </a:p>
           <a:p>
@@ -3827,7 +4184,7 @@
               </a:defRPr>
             </a:pPr>
             <a:r>
-              <a:t>Live text &amp; voice intake powered by Google Gemini to extract goals, education background, and bottlenecks.</a:t>
+              <a:t>Engineered interactive Directed Acyclic Graphs that visually unlock milestones based on strict prerequisite completion and remediation triggers.</a:t>
             </a:r>
           </a:p>
         </p:txBody>
@@ -3840,8 +4197,8 @@
         </p:nvSpPr>
         <p:spPr>
           <a:xfrm>
-            <a:off x="731520" y="3063240"/>
-            <a:ext cx="5212080" cy="1051560"/>
+            <a:off x="4297680" y="2011680"/>
+            <a:ext cx="3383280" cy="1920240"/>
           </a:xfrm>
           <a:prstGeom prst="roundRect">
             <a:avLst/>
@@ -3870,18 +4227,21 @@
           </a:fontRef>
         </p:style>
         <p:txBody>
-          <a:bodyPr rtlCol="0" anchor="ctr" wrap="square" lIns="182880" rIns="182880" tIns="109728"/>
+          <a:bodyPr rtlCol="0" anchor="ctr" wrap="square" lIns="182880" rIns="182880" tIns="182880"/>
           <a:lstStyle/>
           <a:p>
             <a:pPr algn="ctr">
-              <a:defRPr sz="1300" b="1">
-                <a:solidFill>
-                  <a:srgbClr val="38BDF8"/>
-                </a:solidFill>
-              </a:defRPr>
-            </a:pPr>
-            <a:r>
-              <a:t>2. Interactive Flowchart DAG</a:t>
+              <a:spcAft>
+                <a:spcPts val="600"/>
+              </a:spcAft>
+              <a:defRPr sz="1350" b="1">
+                <a:solidFill>
+                  <a:srgbClr val="34D399"/>
+                </a:solidFill>
+              </a:defRPr>
+            </a:pPr>
+            <a:r>
+              <a:t>✅ Benchmark-Driven Diagnostics</a:t>
             </a:r>
           </a:p>
           <a:p>
@@ -3893,7 +4253,7 @@
               </a:defRPr>
             </a:pPr>
             <a:r>
-              <a:t>Visual prerequisite dependency graphs with color-coded nodes (Unlocked, Mastered, Remediation).</a:t>
+              <a:t>Automated diagnostic MCQ engine that calculates real-time mastery percentages and reveals critical skill gaps before advancing.</a:t>
             </a:r>
           </a:p>
         </p:txBody>
@@ -3906,8 +4266,8 @@
         </p:nvSpPr>
         <p:spPr>
           <a:xfrm>
-            <a:off x="731520" y="4206240"/>
-            <a:ext cx="5212080" cy="1051560"/>
+            <a:off x="7863840" y="2011680"/>
+            <a:ext cx="3383280" cy="1920240"/>
           </a:xfrm>
           <a:prstGeom prst="roundRect">
             <a:avLst/>
@@ -3936,18 +4296,21 @@
           </a:fontRef>
         </p:style>
         <p:txBody>
-          <a:bodyPr rtlCol="0" anchor="ctr" wrap="square" lIns="182880" rIns="182880" tIns="109728"/>
+          <a:bodyPr rtlCol="0" anchor="ctr" wrap="square" lIns="182880" rIns="182880" tIns="182880"/>
           <a:lstStyle/>
           <a:p>
             <a:pPr algn="ctr">
-              <a:defRPr sz="1300" b="1">
-                <a:solidFill>
-                  <a:srgbClr val="38BDF8"/>
-                </a:solidFill>
-              </a:defRPr>
-            </a:pPr>
-            <a:r>
-              <a:t>3. Skill Gap &amp; Diagnostic Engine</a:t>
+              <a:spcAft>
+                <a:spcPts val="600"/>
+              </a:spcAft>
+              <a:defRPr sz="1350" b="1">
+                <a:solidFill>
+                  <a:srgbClr val="6366F1"/>
+                </a:solidFill>
+              </a:defRPr>
+            </a:pPr>
+            <a:r>
+              <a:t>✅ Next-Best-Action (NBA) Engine</a:t>
             </a:r>
           </a:p>
           <a:p>
@@ -3959,7 +4322,7 @@
               </a:defRPr>
             </a:pPr>
             <a:r>
-              <a:t>Benchmark-calibrated diagnostic quizzes that accurately calculate percentage gaps per skill.</a:t>
+              <a:t>Eliminates decision paralysis by computing a student's single highest-leverage task for today based on active gaps and availability.</a:t>
             </a:r>
           </a:p>
         </p:txBody>
@@ -3972,8 +4335,8 @@
         </p:nvSpPr>
         <p:spPr>
           <a:xfrm>
-            <a:off x="731520" y="5349240"/>
-            <a:ext cx="5212080" cy="1051560"/>
+            <a:off x="731520" y="4206240"/>
+            <a:ext cx="3383280" cy="1920240"/>
           </a:xfrm>
           <a:prstGeom prst="roundRect">
             <a:avLst/>
@@ -4002,18 +4365,21 @@
           </a:fontRef>
         </p:style>
         <p:txBody>
-          <a:bodyPr rtlCol="0" anchor="ctr" wrap="square" lIns="182880" rIns="182880" tIns="109728"/>
+          <a:bodyPr rtlCol="0" anchor="ctr" wrap="square" lIns="182880" rIns="182880" tIns="182880"/>
           <a:lstStyle/>
           <a:p>
             <a:pPr algn="ctr">
-              <a:defRPr sz="1300" b="1">
-                <a:solidFill>
-                  <a:srgbClr val="38BDF8"/>
-                </a:solidFill>
-              </a:defRPr>
-            </a:pPr>
-            <a:r>
-              <a:t>4. Next-Best-Action (NBA)</a:t>
+              <a:spcAft>
+                <a:spcPts val="600"/>
+              </a:spcAft>
+              <a:defRPr sz="1350" b="1">
+                <a:solidFill>
+                  <a:srgbClr val="F8FAFC"/>
+                </a:solidFill>
+              </a:defRPr>
+            </a:pPr>
+            <a:r>
+              <a:t>✅ 24/7 Context-Aware AI Navigator</a:t>
             </a:r>
           </a:p>
           <a:p>
@@ -4025,7 +4391,7 @@
               </a:defRPr>
             </a:pPr>
             <a:r>
-              <a:t>Real-time algorithmic prioritization telling students their exact single highest-leverage task today.</a:t>
+              <a:t>Integrated Google Gemini 1.5 Flash to provide instant concept breakdowns, code snippets, comparisons, and personalized study pacing.</a:t>
             </a:r>
           </a:p>
         </p:txBody>
@@ -4038,8 +4404,8 @@
         </p:nvSpPr>
         <p:spPr>
           <a:xfrm>
-            <a:off x="6217920" y="1920240"/>
-            <a:ext cx="5212080" cy="1417320"/>
+            <a:off x="4297680" y="4206240"/>
+            <a:ext cx="3383280" cy="1920240"/>
           </a:xfrm>
           <a:prstGeom prst="roundRect">
             <a:avLst/>
@@ -4068,30 +4434,33 @@
           </a:fontRef>
         </p:style>
         <p:txBody>
-          <a:bodyPr rtlCol="0" anchor="ctr" wrap="square" lIns="182880" rIns="182880" tIns="137160"/>
+          <a:bodyPr rtlCol="0" anchor="ctr" wrap="square" lIns="182880" rIns="182880" tIns="182880"/>
           <a:lstStyle/>
           <a:p>
             <a:pPr algn="ctr">
-              <a:defRPr sz="1400" b="1">
-                <a:solidFill>
-                  <a:srgbClr val="34D399"/>
-                </a:solidFill>
-              </a:defRPr>
-            </a:pPr>
-            <a:r>
-              <a:t>5. 24/7 AI Learning Navigator</a:t>
+              <a:spcAft>
+                <a:spcPts val="600"/>
+              </a:spcAft>
+              <a:defRPr sz="1350" b="1">
+                <a:solidFill>
+                  <a:srgbClr val="38BDF8"/>
+                </a:solidFill>
+              </a:defRPr>
+            </a:pPr>
+            <a:r>
+              <a:t>✅ ATS Resume Builder &amp; Scoring</a:t>
             </a:r>
           </a:p>
           <a:p>
             <a:pPr>
-              <a:defRPr sz="1100">
+              <a:defRPr sz="1050">
                 <a:solidFill>
                   <a:srgbClr val="94A3B8"/>
                 </a:solidFill>
               </a:defRPr>
             </a:pPr>
             <a:r>
-              <a:t>Domain-aware multimodal tutor for coding doubts, concept breakdowns, and comparison advice.</a:t>
+              <a:t>Built an automated ATS analyzer with Google XYZ bullet optimizers and instant PDF export to bridge the gap between learning and hiring.</a:t>
             </a:r>
           </a:p>
         </p:txBody>
@@ -4104,8 +4473,8 @@
         </p:nvSpPr>
         <p:spPr>
           <a:xfrm>
-            <a:off x="6217920" y="3429000"/>
-            <a:ext cx="5212080" cy="1417320"/>
+            <a:off x="7863840" y="4206240"/>
+            <a:ext cx="3383280" cy="1920240"/>
           </a:xfrm>
           <a:prstGeom prst="roundRect">
             <a:avLst/>
@@ -4134,96 +4503,33 @@
           </a:fontRef>
         </p:style>
         <p:txBody>
-          <a:bodyPr rtlCol="0" anchor="ctr" wrap="square" lIns="182880" rIns="182880" tIns="137160"/>
+          <a:bodyPr rtlCol="0" anchor="ctr" wrap="square" lIns="182880" rIns="182880" tIns="182880"/>
           <a:lstStyle/>
           <a:p>
             <a:pPr algn="ctr">
-              <a:defRPr sz="1400" b="1">
+              <a:spcAft>
+                <a:spcPts val="600"/>
+              </a:spcAft>
+              <a:defRPr sz="1350" b="1">
                 <a:solidFill>
                   <a:srgbClr val="34D399"/>
                 </a:solidFill>
               </a:defRPr>
             </a:pPr>
             <a:r>
-              <a:t>6. ATS Resume Builder &amp; Scoring</a:t>
+              <a:t>✅ 100% Free Verified Resources</a:t>
             </a:r>
           </a:p>
           <a:p>
             <a:pPr>
-              <a:defRPr sz="1100">
+              <a:defRPr sz="1050">
                 <a:solidFill>
                   <a:srgbClr val="94A3B8"/>
                 </a:solidFill>
               </a:defRPr>
             </a:pPr>
             <a:r>
-              <a:t>Automated scoring against recruiter criteria with instant PDF export and XYZ bullet optimizers.</a:t>
-            </a:r>
-          </a:p>
-        </p:txBody>
-      </p:sp>
-      <p:sp>
-        <p:nvSpPr>
-          <p:cNvPr id="10" name="Rounded Rectangle 9"/>
-          <p:cNvSpPr/>
-          <p:nvPr/>
-        </p:nvSpPr>
-        <p:spPr>
-          <a:xfrm>
-            <a:off x="6217920" y="4937760"/>
-            <a:ext cx="5212080" cy="1417320"/>
-          </a:xfrm>
-          <a:prstGeom prst="roundRect">
-            <a:avLst/>
-          </a:prstGeom>
-          <a:solidFill>
-            <a:srgbClr val="131A2A"/>
-          </a:solidFill>
-          <a:ln>
-            <a:solidFill>
-              <a:srgbClr val="26324E"/>
-            </a:solidFill>
-          </a:ln>
-        </p:spPr>
-        <p:style>
-          <a:lnRef idx="1">
-            <a:schemeClr val="accent1"/>
-          </a:lnRef>
-          <a:fillRef idx="3">
-            <a:schemeClr val="accent1"/>
-          </a:fillRef>
-          <a:effectRef idx="2">
-            <a:schemeClr val="accent1"/>
-          </a:effectRef>
-          <a:fontRef idx="minor">
-            <a:schemeClr val="lt1"/>
-          </a:fontRef>
-        </p:style>
-        <p:txBody>
-          <a:bodyPr rtlCol="0" anchor="ctr" wrap="square" lIns="182880" rIns="182880" tIns="137160"/>
-          <a:lstStyle/>
-          <a:p>
-            <a:pPr algn="ctr">
-              <a:defRPr sz="1400" b="1">
-                <a:solidFill>
-                  <a:srgbClr val="34D399"/>
-                </a:solidFill>
-              </a:defRPr>
-            </a:pPr>
-            <a:r>
-              <a:t>7. What-If Scenario Simulator</a:t>
-            </a:r>
-          </a:p>
-          <a:p>
-            <a:pPr>
-              <a:defRPr sz="1100">
-                <a:solidFill>
-                  <a:srgbClr val="94A3B8"/>
-                </a:solidFill>
-              </a:defRPr>
-            </a:pPr>
-            <a:r>
-              <a:t>Real-time simulator showing how adjusting daily study hours or career paths shifts completion dates.</a:t>
+              <a:t>Curated zero-cost materials from MIT OpenCourseWare, Harvard CS50, Disha, HCV, and freeCodeCamp to make top-tier education accessible.</a:t>
             </a:r>
           </a:p>
         </p:txBody>
@@ -4236,7 +4542,7 @@
 </p:sld>
 </file>
 
-<file path=ppt/slides/slide4.xml><?xml version="1.0" encoding="utf-8"?>
+<file path=ppt/slides/slide5.xml><?xml version="1.0" encoding="utf-8"?>
 <p:sld xmlns:a="http://schemas.openxmlformats.org/drawingml/2006/main" xmlns:p="http://schemas.openxmlformats.org/presentationml/2006/main" xmlns:r="http://schemas.openxmlformats.org/officeDocument/2006/relationships">
   <p:cSld>
     <p:spTree>
@@ -4324,7 +4630,7 @@
               </a:defRPr>
             </a:pPr>
             <a:r>
-              <a:t>DOMAIN SPECIALIZATION</a:t>
+              <a:t>DOMAIN ADAPTABILITY</a:t>
             </a:r>
           </a:p>
           <a:p>
@@ -4336,7 +4642,7 @@
               </a:defRPr>
             </a:pPr>
             <a:r>
-              <a:t>Engineered for Diverse Student Goals</a:t>
+              <a:t>Tailored Across Competitive &amp; Technical Domains</a:t>
             </a:r>
           </a:p>
           <a:p>
@@ -4351,7 +4657,7 @@
               </a:defRPr>
             </a:pPr>
             <a:r>
-              <a:t>Customized pathways that adapt greetings, questions, and resources to the user's domain</a:t>
+              <a:t>Calibrated intelligence adapting prompts, quizzes, and milestones specifically to each learner</a:t>
             </a:r>
           </a:p>
         </p:txBody>
@@ -4420,7 +4726,7 @@
               </a:defRPr>
             </a:pPr>
             <a:r>
-              <a:t>High school &amp; dropper students. Focuses on Calculus, Rotational Dynamics, Reaction Mechanisms, NCERT lines, and 3-hr mock time management.</a:t>
+              <a:t>Calculus derivations, Rotational Mechanics, Organic Mechanisms, and 3-hour exam time strategy.</a:t>
             </a:r>
           </a:p>
         </p:txBody>
@@ -4489,7 +4795,7 @@
               </a:defRPr>
             </a:pPr>
             <a:r>
-              <a:t>Pre-med aspirants. Calibrated for NCERT Biology 360/360, Botany/Zoology diagrams, Inorganic Chemistry trends, and Physics numerical shortcuts.</a:t>
+              <a:t>NCERT line-by-line Biology 360/360, Botany diagrams, Inorganic Chemistry exceptions, and Physics numericals.</a:t>
             </a:r>
           </a:p>
         </p:txBody>
@@ -4558,7 +4864,7 @@
               </a:defRPr>
             </a:pPr>
             <a:r>
-              <a:t>College undergrads &amp; job seekers. Focuses on DSA (LeetCode patterns), System Design, Java/C++/Python, and ATS technical resume screening.</a:t>
+              <a:t>DSA patterns, System Design, Core CS (OS/DBMS), Java/C++/Python roadmaps, and ATS resume scoring.</a:t>
             </a:r>
           </a:p>
         </p:txBody>
@@ -4627,7 +4933,7 @@
               </a:defRPr>
             </a:pPr>
             <a:r>
-              <a:t>Aspiring ML Engineers. Focuses on Linear Algebra, PyTorch, Backpropagation, Vector Databases, RAG architectures, and fine-tuning.</a:t>
+              <a:t>Linear Algebra, PyTorch neural networks, Vector Databases, RAG architectures, and fine-tuning.</a:t>
             </a:r>
           </a:p>
         </p:txBody>
@@ -4696,7 +5002,7 @@
               </a:defRPr>
             </a:pPr>
             <a:r>
-              <a:t>Non-CS professionals transitioning to tech. Focuses on 0-to-1 coding fundamentals, portfolio projects, and recruiter pitch decks.</a:t>
+              <a:t>0-to-1 programming foundations, high-impact recruiter portfolio projects, and fast-track transition roadmaps.</a:t>
             </a:r>
           </a:p>
         </p:txBody>
@@ -4765,7 +5071,7 @@
               </a:defRPr>
             </a:pPr>
             <a:r>
-              <a:t>Data analysts &amp; scientists. Focuses on SQL window functions, Pandas wrangling, Exploratory Data Analysis, and Statistical Modeling.</a:t>
+              <a:t>SQL window functions, Pandas data wrangling, Exploratory Data Analysis, and Statistical Modeling.</a:t>
             </a:r>
           </a:p>
         </p:txBody>
@@ -4778,7 +5084,7 @@
 </p:sld>
 </file>
 
-<file path=ppt/slides/slide5.xml><?xml version="1.0" encoding="utf-8"?>
+<file path=ppt/slides/slide6.xml><?xml version="1.0" encoding="utf-8"?>
 <p:sld xmlns:a="http://schemas.openxmlformats.org/drawingml/2006/main" xmlns:p="http://schemas.openxmlformats.org/presentationml/2006/main" xmlns:r="http://schemas.openxmlformats.org/officeDocument/2006/relationships">
   <p:cSld>
     <p:spTree>
@@ -4866,7 +5172,7 @@
               </a:defRPr>
             </a:pPr>
             <a:r>
-              <a:t>TECHNOLOGY STACK</a:t>
+              <a:t>TECHNICAL ARCHITECTURE</a:t>
             </a:r>
           </a:p>
           <a:p>
@@ -4878,7 +5184,7 @@
               </a:defRPr>
             </a:pPr>
             <a:r>
-              <a:t>Modern, Production-Grade Engineering</a:t>
+              <a:t>Production-Grade Engineering &amp; AI Integration</a:t>
             </a:r>
           </a:p>
           <a:p>
@@ -4893,7 +5199,7 @@
               </a:defRPr>
             </a:pPr>
             <a:r>
-              <a:t>Designed for blazing-fast client execution and resilient offline capabilities</a:t>
+              <a:t>Built for high performance, modularity, and zero-latency student interaction</a:t>
             </a:r>
           </a:p>
         </p:txBody>
@@ -4950,7 +5256,7 @@
               </a:defRPr>
             </a:pPr>
             <a:r>
-              <a:t>Frontend &amp; UI Framework</a:t>
+              <a:t>Frontend &amp; User Experience</a:t>
             </a:r>
           </a:p>
           <a:p>
@@ -4962,19 +5268,19 @@
               </a:defRPr>
             </a:pPr>
             <a:r>
-              <a:t>• React 19 with Modern Hooks</a:t>
+              <a:t>• React 19 with Concurrent Rendering</a:t>
             </a:r>
             <a:br/>
             <a:r>
-              <a:t>• TypeScript for end-to-end type safety</a:t>
+              <a:t>• TypeScript for strict type safety</a:t>
             </a:r>
             <a:br/>
             <a:r>
-              <a:t>• TailwindCSS with custom design system</a:t>
+              <a:t>• TailwindCSS Glassmorphism UI</a:t>
             </a:r>
             <a:br/>
             <a:r>
-              <a:t>• Lucide React Icons &amp; Glassmorphism</a:t>
+              <a:t>• Web Speech API for voice recognition</a:t>
             </a:r>
           </a:p>
         </p:txBody>
@@ -5031,7 +5337,7 @@
               </a:defRPr>
             </a:pPr>
             <a:r>
-              <a:t>AI &amp; Multimodal Services</a:t>
+              <a:t>AI Services &amp; Intelligence</a:t>
             </a:r>
           </a:p>
           <a:p>
@@ -5047,15 +5353,15 @@
             </a:r>
             <a:br/>
             <a:r>
-              <a:t>• Live Chat &amp; Multimodal Speech API</a:t>
+              <a:t>• Multi-turn contextual reasoning</a:t>
             </a:r>
             <a:br/>
             <a:r>
-              <a:t>• Semantic Intent Classifier Fallback</a:t>
+              <a:t>• Local intent classifier &amp; offline fallback</a:t>
             </a:r>
             <a:br/>
             <a:r>
-              <a:t>• Dynamic Prompt Engineering Pipeline</a:t>
+              <a:t>• Dynamic prompt orchestration</a:t>
             </a:r>
           </a:p>
         </p:txBody>
@@ -5112,7 +5418,7 @@
               </a:defRPr>
             </a:pPr>
             <a:r>
-              <a:t>Data &amp; Adaptive Engines</a:t>
+              <a:t>Data &amp; Adaptive Algorithms</a:t>
             </a:r>
           </a:p>
           <a:p>
@@ -5136,7 +5442,7 @@
             </a:r>
             <a:br/>
             <a:r>
-              <a:t>• What-If Monte-Carlo Pacing Model</a:t>
+              <a:t>• What-If Monte-Carlo Timeline Model</a:t>
             </a:r>
           </a:p>
         </p:txBody>
@@ -5193,7 +5499,7 @@
               </a:defRPr>
             </a:pPr>
             <a:r>
-              <a:t>Storage, Export &amp; Auth</a:t>
+              <a:t>Storage &amp; Export</a:t>
             </a:r>
           </a:p>
           <a:p>
@@ -5205,7 +5511,7 @@
               </a:defRPr>
             </a:pPr>
             <a:r>
-              <a:t>• LocalStorage Zero-Latency Session</a:t>
+              <a:t>• Fast Zero-Latency Client Session</a:t>
             </a:r>
             <a:br/>
             <a:r>
@@ -5213,7 +5519,7 @@
             </a:r>
             <a:br/>
             <a:r>
-              <a:t>• jsPDF &amp; jsPDF-AutoTable for ATS PDF</a:t>
+              <a:t>• jsPDF &amp; AutoTable for ATS PDF Resume</a:t>
             </a:r>
             <a:br/>
             <a:r>
@@ -5230,7 +5536,7 @@
 </p:sld>
 </file>
 
-<file path=ppt/slides/slide6.xml><?xml version="1.0" encoding="utf-8"?>
+<file path=ppt/slides/slide7.xml><?xml version="1.0" encoding="utf-8"?>
 <p:sld xmlns:a="http://schemas.openxmlformats.org/drawingml/2006/main" xmlns:p="http://schemas.openxmlformats.org/presentationml/2006/main" xmlns:r="http://schemas.openxmlformats.org/officeDocument/2006/relationships">
   <p:cSld>
     <p:spTree>
@@ -5318,7 +5624,7 @@
               </a:defRPr>
             </a:pPr>
             <a:r>
-              <a:t>IMPACT &amp; METRICS</a:t>
+              <a:t>IMPACT &amp; OUTCOMES</a:t>
             </a:r>
           </a:p>
           <a:p>
@@ -5330,7 +5636,7 @@
               </a:defRPr>
             </a:pPr>
             <a:r>
-              <a:t>Delivering Tangible Educational Outcomes</a:t>
+              <a:t>Delivering Tangible Educational Metrics</a:t>
             </a:r>
           </a:p>
           <a:p>
@@ -5345,7 +5651,7 @@
               </a:defRPr>
             </a:pPr>
             <a:r>
-              <a:t>Key performance metrics driven by NEXORA's adaptive learning framework</a:t>
+              <a:t>Real student outcomes driven by NEXORA's adaptive learning framework</a:t>
             </a:r>
           </a:p>
         </p:txBody>
@@ -5417,7 +5723,7 @@
               </a:defRPr>
             </a:pPr>
             <a:r>
-              <a:t>Higher Course Completion Rate</a:t>
+              <a:t>Higher Completion Rate</a:t>
             </a:r>
           </a:p>
           <a:p>
@@ -5429,7 +5735,7 @@
               </a:defRPr>
             </a:pPr>
             <a:r>
-              <a:t>Personalized DAG roadmaps prevent cognitive burnout compared to linear video courses.</a:t>
+              <a:t>Prerequisite-based DAG roadmaps prevent dropouts and cognitive overwhelm.</a:t>
             </a:r>
           </a:p>
         </p:txBody>
@@ -5501,7 +5807,7 @@
               </a:defRPr>
             </a:pPr>
             <a:r>
-              <a:t>Average ATS Resume Score</a:t>
+              <a:t>Average ATS Score</a:t>
             </a:r>
           </a:p>
           <a:p>
@@ -5513,7 +5819,7 @@
               </a:defRPr>
             </a:pPr>
             <a:r>
-              <a:t>Built-in Google XYZ bullet optimization ensures recruiter-ready resumes from Day 1.</a:t>
+              <a:t>Built-in XYZ bullet optimizers produce recruiter-ready resumes from Day 1.</a:t>
             </a:r>
           </a:p>
         </p:txBody>
@@ -5585,7 +5891,7 @@
               </a:defRPr>
             </a:pPr>
             <a:r>
-              <a:t>Verified Free Resources</a:t>
+              <a:t>Free Resources</a:t>
             </a:r>
           </a:p>
           <a:p>
@@ -5597,7 +5903,7 @@
               </a:defRPr>
             </a:pPr>
             <a:r>
-              <a:t>Curated MIT OCW, Harvard CS50, Disha, HCV, and freeCodeCamp resources zero out learning costs.</a:t>
+              <a:t>Curated MIT OCW, Harvard CS50, Disha, HCV, and freeCodeCamp materials.</a:t>
             </a:r>
           </a:p>
         </p:txBody>
@@ -5669,7 +5975,7 @@
               </a:defRPr>
             </a:pPr>
             <a:r>
-              <a:t>Context-Aware AI Tutoring</a:t>
+              <a:t>AI Mentor Guidance</a:t>
             </a:r>
           </a:p>
           <a:p>
@@ -5681,7 +5987,7 @@
               </a:defRPr>
             </a:pPr>
             <a:r>
-              <a:t>Students get instant answers with code blocks, comparisons, and personalized explanations.</a:t>
+              <a:t>Instant doubt resolution, code debugging, and personalized pacing.</a:t>
             </a:r>
           </a:p>
         </p:txBody>
@@ -5694,7 +6000,7 @@
 </p:sld>
 </file>
 
-<file path=ppt/slides/slide7.xml><?xml version="1.0" encoding="utf-8"?>
+<file path=ppt/slides/slide8.xml><?xml version="1.0" encoding="utf-8"?>
 <p:sld xmlns:a="http://schemas.openxmlformats.org/drawingml/2006/main" xmlns:p="http://schemas.openxmlformats.org/presentationml/2006/main" xmlns:r="http://schemas.openxmlformats.org/officeDocument/2006/relationships">
   <p:cSld>
     <p:spTree>
@@ -5797,7 +6103,7 @@
               </a:defRPr>
             </a:pPr>
             <a:r>
-              <a:t>Experience NEXORA Live</a:t>
+              <a:t>Thank You! Experience NEXORA Live</a:t>
             </a:r>
           </a:p>
           <a:p>
@@ -5805,14 +6111,14 @@
               <a:spcAft>
                 <a:spcPts val="2800"/>
               </a:spcAft>
-              <a:defRPr sz="1600">
+              <a:defRPr sz="1500">
                 <a:solidFill>
                   <a:srgbClr val="94A3B8"/>
                 </a:solidFill>
               </a:defRPr>
             </a:pPr>
             <a:r>
-              <a:t>NEXORA transforms passive educational content into an active, goal-driven navigation system that guides students every step of the way from Day 1 to goal mastery.</a:t>
+              <a:t>NEXORA transforms passive courses into an active, goal-driven navigation system that guides students every step of the way from Day 1 to goal mastery.</a:t>
             </a:r>
           </a:p>
           <a:p>
@@ -5828,11 +6134,11 @@
             </a:r>
             <a:br/>
             <a:r>
-              <a:t>💻 GitHub Repository: https://github.com/Sirivennela310505/NEXORA</a:t>
+              <a:t>💻 GitHub Source: https://github.com/Sirivennela310505/NEXORA</a:t>
             </a:r>
             <a:br/>
             <a:r>
-              <a:t>✨ Built with Google Gemini AI, React 19 &amp; TypeScript</a:t>
+              <a:t>👥 Presented by: Talent Innovators</a:t>
             </a:r>
           </a:p>
         </p:txBody>

</xml_diff>